<commit_message>
added devops web link
</commit_message>
<xml_diff>
--- a/unit-3/talk-3-ict-skills/intro.pptx
+++ b/unit-3/talk-3-ict-skills/intro.pptx
@@ -6252,7 +6252,7 @@
           <a:p>
             <a:fld id="{7FA44F20-A97B-47AA-A242-987ACB3E7403}" type="datetimeFigureOut">
               <a:rPr lang="en-IE" smtClean="0"/>
-              <a:t>12/01/2024</a:t>
+              <a:t>09/01/2025</a:t>
             </a:fld>
             <a:endParaRPr lang="en-IE"/>
           </a:p>
@@ -6452,7 +6452,7 @@
           <a:p>
             <a:fld id="{7FA44F20-A97B-47AA-A242-987ACB3E7403}" type="datetimeFigureOut">
               <a:rPr lang="en-IE" smtClean="0"/>
-              <a:t>12/01/2024</a:t>
+              <a:t>09/01/2025</a:t>
             </a:fld>
             <a:endParaRPr lang="en-IE"/>
           </a:p>
@@ -6662,7 +6662,7 @@
           <a:p>
             <a:fld id="{7FA44F20-A97B-47AA-A242-987ACB3E7403}" type="datetimeFigureOut">
               <a:rPr lang="en-IE" smtClean="0"/>
-              <a:t>12/01/2024</a:t>
+              <a:t>09/01/2025</a:t>
             </a:fld>
             <a:endParaRPr lang="en-IE"/>
           </a:p>
@@ -6862,7 +6862,7 @@
           <a:p>
             <a:fld id="{7FA44F20-A97B-47AA-A242-987ACB3E7403}" type="datetimeFigureOut">
               <a:rPr lang="en-IE" smtClean="0"/>
-              <a:t>12/01/2024</a:t>
+              <a:t>09/01/2025</a:t>
             </a:fld>
             <a:endParaRPr lang="en-IE"/>
           </a:p>
@@ -7138,7 +7138,7 @@
           <a:p>
             <a:fld id="{7FA44F20-A97B-47AA-A242-987ACB3E7403}" type="datetimeFigureOut">
               <a:rPr lang="en-IE" smtClean="0"/>
-              <a:t>12/01/2024</a:t>
+              <a:t>09/01/2025</a:t>
             </a:fld>
             <a:endParaRPr lang="en-IE"/>
           </a:p>
@@ -7406,7 +7406,7 @@
           <a:p>
             <a:fld id="{7FA44F20-A97B-47AA-A242-987ACB3E7403}" type="datetimeFigureOut">
               <a:rPr lang="en-IE" smtClean="0"/>
-              <a:t>12/01/2024</a:t>
+              <a:t>09/01/2025</a:t>
             </a:fld>
             <a:endParaRPr lang="en-IE"/>
           </a:p>
@@ -7821,7 +7821,7 @@
           <a:p>
             <a:fld id="{7FA44F20-A97B-47AA-A242-987ACB3E7403}" type="datetimeFigureOut">
               <a:rPr lang="en-IE" smtClean="0"/>
-              <a:t>12/01/2024</a:t>
+              <a:t>09/01/2025</a:t>
             </a:fld>
             <a:endParaRPr lang="en-IE"/>
           </a:p>
@@ -7963,7 +7963,7 @@
           <a:p>
             <a:fld id="{7FA44F20-A97B-47AA-A242-987ACB3E7403}" type="datetimeFigureOut">
               <a:rPr lang="en-IE" smtClean="0"/>
-              <a:t>12/01/2024</a:t>
+              <a:t>09/01/2025</a:t>
             </a:fld>
             <a:endParaRPr lang="en-IE"/>
           </a:p>
@@ -8076,7 +8076,7 @@
           <a:p>
             <a:fld id="{7FA44F20-A97B-47AA-A242-987ACB3E7403}" type="datetimeFigureOut">
               <a:rPr lang="en-IE" smtClean="0"/>
-              <a:t>12/01/2024</a:t>
+              <a:t>09/01/2025</a:t>
             </a:fld>
             <a:endParaRPr lang="en-IE"/>
           </a:p>
@@ -8389,7 +8389,7 @@
           <a:p>
             <a:fld id="{7FA44F20-A97B-47AA-A242-987ACB3E7403}" type="datetimeFigureOut">
               <a:rPr lang="en-IE" smtClean="0"/>
-              <a:t>12/01/2024</a:t>
+              <a:t>09/01/2025</a:t>
             </a:fld>
             <a:endParaRPr lang="en-IE"/>
           </a:p>
@@ -8678,7 +8678,7 @@
           <a:p>
             <a:fld id="{7FA44F20-A97B-47AA-A242-987ACB3E7403}" type="datetimeFigureOut">
               <a:rPr lang="en-IE" smtClean="0"/>
-              <a:t>12/01/2024</a:t>
+              <a:t>09/01/2025</a:t>
             </a:fld>
             <a:endParaRPr lang="en-IE"/>
           </a:p>
@@ -8921,7 +8921,7 @@
           <a:p>
             <a:fld id="{7FA44F20-A97B-47AA-A242-987ACB3E7403}" type="datetimeFigureOut">
               <a:rPr lang="en-IE" smtClean="0"/>
-              <a:t>12/01/2024</a:t>
+              <a:t>09/01/2025</a:t>
             </a:fld>
             <a:endParaRPr lang="en-IE"/>
           </a:p>
@@ -9418,13 +9418,13 @@
           <a:p>
             <a:r>
               <a:rPr lang="en-IE" i="1" dirty="0"/>
-              <a:t>Frank Walsh, Diarmuid O’Connor</a:t>
+              <a:t>Frank Walsh</a:t>
             </a:r>
           </a:p>
           <a:p>
             <a:r>
               <a:rPr lang="en-IE" i="1" dirty="0"/>
-              <a:t>Jan 2024</a:t>
+              <a:t>Jan 2025</a:t>
             </a:r>
           </a:p>
         </p:txBody>

</xml_diff>